<commit_message>
Add epidural depot model approximation and spinal exclusion discussion
- Added new section: Considerations for neuraxial techniques (epidural and spinal)
- Epidural: emphasized depot model CAN adequately approximate epidural pharmacokinetics
- Spinal: excluded due to unique CSF dynamics, small doses, single-shot nature
- Updated Table 1 with epidural administration row in all files (docx + pptx)
- Added spinal exclusion footnote to PPTX Table 1 slides
- Updated limitations section to reference neuraxial considerations
- All changes applied to both English and Japanese versions

Co-Authored-By: Tatsuki Onishi <bougtoir@gmail.com>
</commit_message>
<xml_diff>
--- a/bja-initial-compartment-pk/BJA_Figures_English.pptx
+++ b/bja-initial-compartment-pk/BJA_Figures_English.pptx
@@ -5517,7 +5517,7 @@
                 <a:gridCol w="2103120"/>
                 <a:gridCol w="2743200"/>
               </a:tblGrid>
-              <a:tr h="822960">
+              <a:tr h="685800">
                 <a:tc>
                   <a:txBody>
                     <a:bodyPr/>
@@ -5611,7 +5611,7 @@
                   </a:tcPr>
                 </a:tc>
               </a:tr>
-              <a:tr h="822960">
+              <a:tr h="685800">
                 <a:tc>
                   <a:txBody>
                     <a:bodyPr/>
@@ -5729,7 +5729,7 @@
                   </a:tcPr>
                 </a:tc>
               </a:tr>
-              <a:tr h="822960">
+              <a:tr h="685800">
                 <a:tc>
                   <a:txBody>
                     <a:bodyPr/>
@@ -5835,7 +5835,7 @@
                   </a:tcPr>
                 </a:tc>
               </a:tr>
-              <a:tr h="822960">
+              <a:tr h="685800">
                 <a:tc>
                   <a:txBody>
                     <a:bodyPr/>
@@ -5953,7 +5953,7 @@
                   </a:tcPr>
                 </a:tc>
               </a:tr>
-              <a:tr h="822960">
+              <a:tr h="685800">
                 <a:tc>
                   <a:txBody>
                     <a:bodyPr/>
@@ -6047,10 +6047,167 @@
                   </a:tcPr>
                 </a:tc>
               </a:tr>
+              <a:tr h="685800">
+                <a:tc>
+                  <a:txBody>
+                    <a:bodyPr/>
+                    <a:lstStyle/>
+                    <a:p>
+                      <a:pPr algn="ctr">
+                        <a:defRPr sz="1200">
+                          <a:solidFill>
+                            <a:srgbClr val="000000"/>
+                          </a:solidFill>
+                        </a:defRPr>
+                      </a:pPr>
+                      <a:r>
+                        <a:t>Epidural administration</a:t>
+                      </a:r>
+                    </a:p>
+                  </a:txBody>
+                  <a:tcPr anchor="ctr">
+                    <a:solidFill>
+                      <a:srgbClr val="F3E5F5"/>
+                    </a:solidFill>
+                  </a:tcPr>
+                </a:tc>
+                <a:tc>
+                  <a:txBody>
+                    <a:bodyPr/>
+                    <a:lstStyle/>
+                    <a:p>
+                      <a:pPr algn="ctr">
+                        <a:defRPr sz="1200">
+                          <a:solidFill>
+                            <a:srgbClr val="000000"/>
+                          </a:solidFill>
+                        </a:defRPr>
+                      </a:pPr>
+                      <a:r>
+                        <a:t>Depot (multi-pathway)</a:t>
+                      </a:r>
+                    </a:p>
+                    <a:p>
+                      <a:pPr algn="ctr">
+                        <a:defRPr sz="1200">
+                          <a:solidFill>
+                            <a:srgbClr val="000000"/>
+                          </a:solidFill>
+                        </a:defRPr>
+                      </a:pPr>
+                      <a:r>
+                        <a:t>Fat + dural transfer + vascular</a:t>
+                      </a:r>
+                    </a:p>
+                  </a:txBody>
+                  <a:tcPr anchor="ctr">
+                    <a:solidFill>
+                      <a:srgbClr val="F3E5F5"/>
+                    </a:solidFill>
+                  </a:tcPr>
+                </a:tc>
+                <a:tc>
+                  <a:txBody>
+                    <a:bodyPr/>
+                    <a:lstStyle/>
+                    <a:p>
+                      <a:pPr algn="ctr">
+                        <a:defRPr sz="1200">
+                          <a:solidFill>
+                            <a:srgbClr val="000000"/>
+                          </a:solidFill>
+                        </a:defRPr>
+                      </a:pPr>
+                      <a:r>
+                        <a:t>Intermediate, delayed</a:t>
+                      </a:r>
+                    </a:p>
+                  </a:txBody>
+                  <a:tcPr anchor="ctr">
+                    <a:solidFill>
+                      <a:srgbClr val="F3E5F5"/>
+                    </a:solidFill>
+                  </a:tcPr>
+                </a:tc>
+                <a:tc>
+                  <a:txBody>
+                    <a:bodyPr/>
+                    <a:lstStyle/>
+                    <a:p>
+                      <a:pPr algn="ctr">
+                        <a:defRPr sz="1200">
+                          <a:solidFill>
+                            <a:srgbClr val="000000"/>
+                          </a:solidFill>
+                        </a:defRPr>
+                      </a:pPr>
+                      <a:r>
+                        <a:t>Adequately approximated</a:t>
+                      </a:r>
+                    </a:p>
+                    <a:p>
+                      <a:pPr algn="ctr">
+                        <a:defRPr sz="1200">
+                          <a:solidFill>
+                            <a:srgbClr val="000000"/>
+                          </a:solidFill>
+                        </a:defRPr>
+                      </a:pPr>
+                      <a:r>
+                        <a:t>by depot model</a:t>
+                      </a:r>
+                    </a:p>
+                  </a:txBody>
+                  <a:tcPr anchor="ctr">
+                    <a:solidFill>
+                      <a:srgbClr val="F3E5F5"/>
+                    </a:solidFill>
+                  </a:tcPr>
+                </a:tc>
+              </a:tr>
             </a:tbl>
           </a:graphicData>
         </a:graphic>
       </p:graphicFrame>
+      <p:sp>
+        <p:nvSpPr>
+          <p:cNvPr id="4" name="TextBox 3"/>
+          <p:cNvSpPr txBox="1"/>
+          <p:nvPr/>
+        </p:nvSpPr>
+        <p:spPr>
+          <a:xfrm>
+            <a:off x="822960" y="5486400"/>
+            <a:ext cx="10515600" cy="640080"/>
+          </a:xfrm>
+          <a:prstGeom prst="rect">
+            <a:avLst/>
+          </a:prstGeom>
+          <a:noFill/>
+        </p:spPr>
+        <p:txBody>
+          <a:bodyPr wrap="square">
+            <a:spAutoFit/>
+          </a:bodyPr>
+          <a:lstStyle/>
+          <a:p>
+            <a:pPr algn="l">
+              <a:defRPr sz="1000" b="0">
+                <a:solidFill>
+                  <a:srgbClr val="9E9E9E"/>
+                </a:solidFill>
+              </a:defRPr>
+            </a:pPr>
+            <a:r>
+              <a:t>Note: Spinal (intrathecal) anaesthesia was excluded from this framework due to unique CSF pharmacokinetics,</a:t>
+            </a:r>
+            <a:br/>
+            <a:r>
+              <a:t>small doses employed, and predominantly single-shot nature of the technique.</a:t>
+            </a:r>
+          </a:p>
+        </p:txBody>
+      </p:sp>
     </p:spTree>
   </p:cSld>
   <p:clrMapOvr>

</xml_diff>